<commit_message>
Fix Docker import path, polish UI, refresh docs and README visuals
- Dockerfile: add PYTHONPATH=/app so job_agent imports resolve under
  Streamlit's run command (fixes ModuleNotFoundError in the container).
- Streamlit app: sidebar nav, refined auth and baseline-CV profile pages.
- README: animated pipeline/state/validation-loop diagrams, app
  screenshot, and a corrected test/coverage badge (588 tests, 96%
  coverage - was stale at 434/98%). Same fix applied in
  docs/PROJECT_EXPLANATION.md.

Co-Authored-By: Claude Sonnet 5 <noreply@anthropic.com>
</commit_message>
<xml_diff>
--- a/docs/Job_Application_Agent_Presentation.pptx
+++ b/docs/Job_Application_Agent_Presentation.pptx
@@ -17,6 +17,10 @@
     <p:sldId id="265" r:id="rId17"/>
     <p:sldId id="266" r:id="rId18"/>
     <p:sldId id="267" r:id="rId19"/>
+    <p:sldId id="272" r:id="rId24"/>
+    <p:sldId id="273" r:id="rId25"/>
+    <p:sldId id="274" r:id="rId26"/>
+    <p:sldId id="275" r:id="rId27"/>
     <p:sldId id="268" r:id="rId20"/>
     <p:sldId id="269" r:id="rId21"/>
     <p:sldId id="270" r:id="rId22"/>
@@ -6869,7 +6873,7 @@
                 </a:solidFill>
                 <a:latin typeface="Calibri"/>
               </a:rPr>
-              <a:t>▪  CV + JD input (paste or upload .txt/.md/.pdf)</a:t>
+              <a:t>▪  Job description input (your saved baseline CV is used automatically)</a:t>
             </a:r>
           </a:p>
           <a:p>
@@ -6885,7 +6889,7 @@
                 </a:solidFill>
                 <a:latin typeface="Calibri"/>
               </a:rPr>
-              <a:t>▪  Pipeline progress, reconstructed from the real trace</a:t>
+              <a:t>▪  A clean loading screen, showing real progress stage by stage</a:t>
             </a:r>
           </a:p>
           <a:p>
@@ -7818,7 +7822,7 @@
                 </a:solidFill>
                 <a:latin typeface="Calibri"/>
               </a:rPr>
-              <a:t>434</a:t>
+              <a:t>588</a:t>
             </a:r>
           </a:p>
         </p:txBody>
@@ -7908,7 +7912,7 @@
                 </a:solidFill>
                 <a:latin typeface="Calibri"/>
               </a:rPr>
-              <a:t>98%</a:t>
+              <a:t>96%</a:t>
             </a:r>
           </a:p>
         </p:txBody>
@@ -8316,7 +8320,7 @@
                 </a:solidFill>
                 <a:latin typeface="Calibri"/>
               </a:rPr>
-              <a:t>13</a:t>
+              <a:t>17</a:t>
             </a:r>
           </a:p>
         </p:txBody>
@@ -9835,7 +9839,7 @@
                 </a:solidFill>
                 <a:latin typeface="Calibri"/>
               </a:rPr>
-              <a:t>14</a:t>
+              <a:t>18</a:t>
             </a:r>
           </a:p>
         </p:txBody>
@@ -10177,7 +10181,7 @@
                 </a:solidFill>
                 <a:latin typeface="Calibri"/>
               </a:rPr>
-              <a:t>▪  No company-research caching</a:t>
+              <a:t>▪  Vector DB intentionally not added — no genuine semantic-retrieval need was found</a:t>
             </a:r>
           </a:p>
         </p:txBody>
@@ -10287,7 +10291,7 @@
                 </a:solidFill>
                 <a:latin typeface="Calibri"/>
               </a:rPr>
-              <a:t>▪  Cache company research per company</a:t>
+              <a:t>▪  Provider switching is a .env edit today, not a saved UI preset</a:t>
             </a:r>
           </a:p>
           <a:p>
@@ -10405,7 +10409,7 @@
                 </a:solidFill>
                 <a:latin typeface="Calibri"/>
               </a:rPr>
-              <a:t>15</a:t>
+              <a:t>19</a:t>
             </a:r>
           </a:p>
         </p:txBody>
@@ -10597,7 +10601,7 @@
                 </a:solidFill>
                 <a:latin typeface="Calibri"/>
               </a:rPr>
-              <a:t>▪  434 tests, 98% coverage, clean lint, committed and pushed</a:t>
+              <a:t>▪  588 tests, 96% coverage, clean lint, committed and pushed</a:t>
             </a:r>
           </a:p>
         </p:txBody>
@@ -10652,7 +10656,7 @@
                 </a:solidFill>
                 <a:latin typeface="Calibri"/>
               </a:rPr>
-              <a:t>Live demo: paste a CV + job description → Run application → walk through the fit report, grounding panel, and tracker</a:t>
+              <a:t>Live demo: sign in, paste a job description → Start Analysis → walk through the visual summary, fit report, and tailored CV history</a:t>
             </a:r>
           </a:p>
         </p:txBody>
@@ -10757,7 +10761,1510 @@
                 </a:solidFill>
                 <a:latin typeface="Calibri"/>
               </a:rPr>
-              <a:t>16</a:t>
+              <a:t>20</a:t>
+            </a:r>
+          </a:p>
+        </p:txBody>
+      </p:sp>
+    </p:spTree>
+  </p:cSld>
+  <p:clrMapOvr>
+    <a:masterClrMapping/>
+  </p:clrMapOvr>
+</p:sld>
+</file>
+
+<file path=ppt/slides/slide17.xml><?xml version="1.0" encoding="utf-8"?>
+<p:sld xmlns:a="http://schemas.openxmlformats.org/drawingml/2006/main" xmlns:p="http://schemas.openxmlformats.org/presentationml/2006/main" xmlns:r="http://schemas.openxmlformats.org/officeDocument/2006/relationships">
+  <p:cSld>
+    <p:bg>
+      <p:bgPr>
+        <a:solidFill>
+          <a:srgbClr val="FFFFFF"/>
+        </a:solidFill>
+        <a:effectLst/>
+      </p:bgPr>
+    </p:bg>
+    <p:spTree>
+      <p:nvGrpSpPr>
+        <p:cNvPr id="1" name=""/>
+        <p:cNvGrpSpPr/>
+        <p:nvPr/>
+      </p:nvGrpSpPr>
+      <p:grpSpPr/>
+      <p:sp>
+        <p:nvSpPr>
+          <p:cNvPr id="2" name="Rectangle 1"/>
+          <p:cNvSpPr/>
+          <p:nvPr/>
+        </p:nvSpPr>
+        <p:spPr>
+          <a:xfrm>
+            <a:off x="0" y="0"/>
+            <a:ext cx="12191695" cy="109728"/>
+          </a:xfrm>
+          <a:prstGeom prst="rect">
+            <a:avLst/>
+          </a:prstGeom>
+          <a:solidFill>
+            <a:srgbClr val="2B6CB0"/>
+          </a:solidFill>
+          <a:ln>
+            <a:noFill/>
+          </a:ln>
+          <a:effectLst/>
+        </p:spPr>
+        <p:style>
+          <a:lnRef idx="1">
+            <a:schemeClr val="accent1"/>
+          </a:lnRef>
+          <a:fillRef idx="3">
+            <a:schemeClr val="accent1"/>
+          </a:fillRef>
+          <a:effectRef idx="2">
+            <a:schemeClr val="accent1"/>
+          </a:effectRef>
+          <a:fontRef idx="minor">
+            <a:schemeClr val="lt1"/>
+          </a:fontRef>
+        </p:style>
+        <p:txBody>
+          <a:bodyPr rtlCol="0" anchor="ctr"/>
+          <a:lstStyle/>
+          <a:p>
+            <a:pPr algn="ctr"/>
+          </a:p>
+        </p:txBody>
+      </p:sp>
+      <p:sp>
+        <p:nvSpPr>
+          <p:cNvPr id="3" name="TextBox 2"/>
+          <p:cNvSpPr txBox="1"/>
+          <p:nvPr/>
+        </p:nvSpPr>
+        <p:spPr>
+          <a:xfrm>
+            <a:off x="502920" y="256032"/>
+            <a:ext cx="10058400" cy="320040"/>
+          </a:xfrm>
+          <a:prstGeom prst="rect">
+            <a:avLst/>
+          </a:prstGeom>
+          <a:noFill/>
+        </p:spPr>
+        <p:txBody>
+          <a:bodyPr wrap="square">
+            <a:spAutoFit/>
+          </a:bodyPr>
+          <a:lstStyle/>
+          <a:p>
+            <a:pPr algn="l"/>
+            <a:r>
+              <a:rPr sz="1300" b="1" i="0">
+                <a:solidFill>
+                  <a:srgbClr val="2B6CB0"/>
+                </a:solidFill>
+                <a:latin typeface="Calibri"/>
+              </a:rPr>
+              <a:t>BEYOND THE CORE PIPELINE</a:t>
+            </a:r>
+          </a:p>
+        </p:txBody>
+      </p:sp>
+      <p:sp>
+        <p:nvSpPr>
+          <p:cNvPr id="4" name="TextBox 3"/>
+          <p:cNvSpPr txBox="1"/>
+          <p:nvPr/>
+        </p:nvSpPr>
+        <p:spPr>
+          <a:xfrm>
+            <a:off x="502920" y="548640"/>
+            <a:ext cx="11155680" cy="640080"/>
+          </a:xfrm>
+          <a:prstGeom prst="rect">
+            <a:avLst/>
+          </a:prstGeom>
+          <a:noFill/>
+        </p:spPr>
+        <p:txBody>
+          <a:bodyPr wrap="square">
+            <a:spAutoFit/>
+          </a:bodyPr>
+          <a:lstStyle/>
+          <a:p>
+            <a:pPr algn="l"/>
+            <a:r>
+              <a:rPr sz="2800" b="1" i="0">
+                <a:solidFill>
+                  <a:srgbClr val="1A2E4A"/>
+                </a:solidFill>
+                <a:latin typeface="Calibri"/>
+              </a:rPr>
+              <a:t>User Accounts &amp; the Baseline CV</a:t>
+            </a:r>
+          </a:p>
+        </p:txBody>
+      </p:sp>
+      <p:sp>
+        <p:nvSpPr>
+          <p:cNvPr id="5" name="Rectangle 4"/>
+          <p:cNvSpPr/>
+          <p:nvPr/>
+        </p:nvSpPr>
+        <p:spPr>
+          <a:xfrm>
+            <a:off x="521207" y="1170432"/>
+            <a:ext cx="1463040" cy="38100"/>
+          </a:xfrm>
+          <a:prstGeom prst="rect">
+            <a:avLst/>
+          </a:prstGeom>
+          <a:solidFill>
+            <a:srgbClr val="2B6CB0"/>
+          </a:solidFill>
+          <a:ln>
+            <a:noFill/>
+          </a:ln>
+          <a:effectLst/>
+        </p:spPr>
+        <p:style>
+          <a:lnRef idx="1">
+            <a:schemeClr val="accent1"/>
+          </a:lnRef>
+          <a:fillRef idx="3">
+            <a:schemeClr val="accent1"/>
+          </a:fillRef>
+          <a:effectRef idx="2">
+            <a:schemeClr val="accent1"/>
+          </a:effectRef>
+          <a:fontRef idx="minor">
+            <a:schemeClr val="lt1"/>
+          </a:fontRef>
+        </p:style>
+        <p:txBody>
+          <a:bodyPr rtlCol="0" anchor="ctr"/>
+          <a:lstStyle/>
+          <a:p>
+            <a:pPr algn="ctr"/>
+          </a:p>
+        </p:txBody>
+      </p:sp>
+      <p:sp>
+        <p:nvSpPr>
+          <p:cNvPr id="6" name="Rounded Rectangle 5"/>
+          <p:cNvSpPr/>
+          <p:nvPr/>
+        </p:nvSpPr>
+        <p:spPr>
+          <a:xfrm>
+            <a:off x="640080" y="1463040"/>
+            <a:ext cx="5212080" cy="457200"/>
+          </a:xfrm>
+          <a:prstGeom prst="roundRect">
+            <a:avLst/>
+          </a:prstGeom>
+          <a:solidFill>
+            <a:srgbClr val="E9F2FB"/>
+          </a:solidFill>
+          <a:ln w="15875">
+            <a:solidFill>
+              <a:srgbClr val="2B6CB0"/>
+            </a:solidFill>
+          </a:ln>
+          <a:effectLst/>
+        </p:spPr>
+        <p:style>
+          <a:lnRef idx="1">
+            <a:schemeClr val="accent1"/>
+          </a:lnRef>
+          <a:fillRef idx="3">
+            <a:schemeClr val="accent1"/>
+          </a:fillRef>
+          <a:effectRef idx="2">
+            <a:schemeClr val="accent1"/>
+          </a:effectRef>
+          <a:fontRef idx="minor">
+            <a:schemeClr val="lt1"/>
+          </a:fontRef>
+        </p:style>
+        <p:txBody>
+          <a:bodyPr rtlCol="0" anchor="ctr" wrap="square" lIns="50800" rIns="50800" tIns="25400" bIns="25400"/>
+          <a:lstStyle/>
+          <a:p>
+            <a:pPr algn="ctr"/>
+            <a:r>
+              <a:rPr sz="1400" b="1" i="0">
+                <a:solidFill>
+                  <a:srgbClr val="1F4E82"/>
+                </a:solidFill>
+                <a:latin typeface="Calibri"/>
+              </a:rPr>
+              <a:t>AUTHENTICATION</a:t>
+            </a:r>
+          </a:p>
+        </p:txBody>
+      </p:sp>
+      <p:sp>
+        <p:nvSpPr>
+          <p:cNvPr id="7" name="TextBox 6"/>
+          <p:cNvSpPr txBox="1"/>
+          <p:nvPr/>
+        </p:nvSpPr>
+        <p:spPr>
+          <a:xfrm>
+            <a:off x="640080" y="2057400"/>
+            <a:ext cx="5212080" cy="3931920"/>
+          </a:xfrm>
+          <a:prstGeom prst="rect">
+            <a:avLst/>
+          </a:prstGeom>
+          <a:noFill/>
+        </p:spPr>
+        <p:txBody>
+          <a:bodyPr wrap="square">
+            <a:spAutoFit/>
+          </a:bodyPr>
+          <a:lstStyle/>
+          <a:p>
+            <a:pPr>
+              <a:spcAft>
+                <a:spcPts val="1600"/>
+              </a:spcAft>
+            </a:pPr>
+            <a:r>
+              <a:rPr sz="1600">
+                <a:solidFill>
+                  <a:srgbClr val="3D4754"/>
+                </a:solidFill>
+                <a:latin typeface="Calibri"/>
+              </a:rPr>
+              <a:t>▪  Email + password signup and login, one account per user</a:t>
+            </a:r>
+          </a:p>
+          <a:p>
+            <a:pPr>
+              <a:spcAft>
+                <a:spcPts val="1600"/>
+              </a:spcAft>
+            </a:pPr>
+            <a:r>
+              <a:rPr sz="1600">
+                <a:solidFill>
+                  <a:srgbClr val="3D4754"/>
+                </a:solidFill>
+                <a:latin typeface="Calibri"/>
+              </a:rPr>
+              <a:t>▪  Passwords are hashed (PBKDF2), never stored in plain text</a:t>
+            </a:r>
+          </a:p>
+          <a:p>
+            <a:pPr>
+              <a:spcAft>
+                <a:spcPts val="1600"/>
+              </a:spcAft>
+            </a:pPr>
+            <a:r>
+              <a:rPr sz="1600">
+                <a:solidFill>
+                  <a:srgbClr val="3D4754"/>
+                </a:solidFill>
+                <a:latin typeface="Calibri"/>
+              </a:rPr>
+              <a:t>▪  Every baseline CV and tailored CV is scoped to one user</a:t>
+            </a:r>
+          </a:p>
+          <a:p>
+            <a:pPr>
+              <a:spcAft>
+                <a:spcPts val="1600"/>
+              </a:spcAft>
+            </a:pPr>
+            <a:r>
+              <a:rPr sz="1600">
+                <a:solidFill>
+                  <a:srgbClr val="3D4754"/>
+                </a:solidFill>
+                <a:latin typeface="Calibri"/>
+              </a:rPr>
+              <a:t>▪  Session-based sidebar shows who is signed in, with a log-out</a:t>
+            </a:r>
+          </a:p>
+        </p:txBody>
+      </p:sp>
+      <p:sp>
+        <p:nvSpPr>
+          <p:cNvPr id="8" name="Rounded Rectangle 7"/>
+          <p:cNvSpPr/>
+          <p:nvPr/>
+        </p:nvSpPr>
+        <p:spPr>
+          <a:xfrm>
+            <a:off x="6217920" y="1463040"/>
+            <a:ext cx="5303520" cy="457200"/>
+          </a:xfrm>
+          <a:prstGeom prst="roundRect">
+            <a:avLst/>
+          </a:prstGeom>
+          <a:solidFill>
+            <a:srgbClr val="E7F5EE"/>
+          </a:solidFill>
+          <a:ln w="15875">
+            <a:solidFill>
+              <a:srgbClr val="2F7D5C"/>
+            </a:solidFill>
+          </a:ln>
+          <a:effectLst/>
+        </p:spPr>
+        <p:style>
+          <a:lnRef idx="1">
+            <a:schemeClr val="accent1"/>
+          </a:lnRef>
+          <a:fillRef idx="3">
+            <a:schemeClr val="accent1"/>
+          </a:fillRef>
+          <a:effectRef idx="2">
+            <a:schemeClr val="accent1"/>
+          </a:effectRef>
+          <a:fontRef idx="minor">
+            <a:schemeClr val="lt1"/>
+          </a:fontRef>
+        </p:style>
+        <p:txBody>
+          <a:bodyPr rtlCol="0" anchor="ctr" wrap="square" lIns="50800" rIns="50800" tIns="25400" bIns="25400"/>
+          <a:lstStyle/>
+          <a:p>
+            <a:pPr algn="ctr"/>
+            <a:r>
+              <a:rPr sz="1400" b="1" i="0">
+                <a:solidFill>
+                  <a:srgbClr val="2F7D5C"/>
+                </a:solidFill>
+                <a:latin typeface="Calibri"/>
+              </a:rPr>
+              <a:t>BASELINE CV</a:t>
+            </a:r>
+          </a:p>
+        </p:txBody>
+      </p:sp>
+      <p:sp>
+        <p:nvSpPr>
+          <p:cNvPr id="9" name="TextBox 8"/>
+          <p:cNvSpPr txBox="1"/>
+          <p:nvPr/>
+        </p:nvSpPr>
+        <p:spPr>
+          <a:xfrm>
+            <a:off x="6217920" y="2057400"/>
+            <a:ext cx="5303520" cy="3931920"/>
+          </a:xfrm>
+          <a:prstGeom prst="rect">
+            <a:avLst/>
+          </a:prstGeom>
+          <a:noFill/>
+        </p:spPr>
+        <p:txBody>
+          <a:bodyPr wrap="square">
+            <a:spAutoFit/>
+          </a:bodyPr>
+          <a:lstStyle/>
+          <a:p>
+            <a:pPr>
+              <a:spcAft>
+                <a:spcPts val="1600"/>
+              </a:spcAft>
+            </a:pPr>
+            <a:r>
+              <a:rPr sz="1600">
+                <a:solidFill>
+                  <a:srgbClr val="3D4754"/>
+                </a:solidFill>
+                <a:latin typeface="Calibri"/>
+              </a:rPr>
+              <a:t>▪  Upload or paste a CV once — the one source of truth</a:t>
+            </a:r>
+          </a:p>
+          <a:p>
+            <a:pPr>
+              <a:spcAft>
+                <a:spcPts val="1600"/>
+              </a:spcAft>
+            </a:pPr>
+            <a:r>
+              <a:rPr sz="1600">
+                <a:solidFill>
+                  <a:srgbClr val="3D4754"/>
+                </a:solidFill>
+                <a:latin typeface="Calibri"/>
+              </a:rPr>
+              <a:t>▪  Edit it in place, or replace it, at any time</a:t>
+            </a:r>
+          </a:p>
+          <a:p>
+            <a:pPr>
+              <a:spcAft>
+                <a:spcPts val="1600"/>
+              </a:spcAft>
+            </a:pPr>
+            <a:r>
+              <a:rPr sz="1600">
+                <a:solidFill>
+                  <a:srgbClr val="3D4754"/>
+                </a:solidFill>
+                <a:latin typeface="Calibri"/>
+              </a:rPr>
+              <a:t>▪  Every tailored application is built from this one CV</a:t>
+            </a:r>
+          </a:p>
+          <a:p>
+            <a:pPr>
+              <a:spcAft>
+                <a:spcPts val="1600"/>
+              </a:spcAft>
+            </a:pPr>
+            <a:r>
+              <a:rPr sz="1600">
+                <a:solidFill>
+                  <a:srgbClr val="3D4754"/>
+                </a:solidFill>
+                <a:latin typeface="Calibri"/>
+              </a:rPr>
+              <a:t>▪  Tailoring reads it — a run never writes back to it</a:t>
+            </a:r>
+          </a:p>
+        </p:txBody>
+      </p:sp>
+      <p:sp>
+        <p:nvSpPr>
+          <p:cNvPr id="10" name="TextBox 10"/>
+          <p:cNvSpPr txBox="1"/>
+          <p:nvPr/>
+        </p:nvSpPr>
+        <p:spPr>
+          <a:xfrm>
+            <a:off x="502920" y="6537960"/>
+            <a:ext cx="5486400" cy="274320"/>
+          </a:xfrm>
+          <a:prstGeom prst="rect">
+            <a:avLst/>
+          </a:prstGeom>
+          <a:noFill/>
+        </p:spPr>
+        <p:txBody>
+          <a:bodyPr wrap="square">
+            <a:spAutoFit/>
+          </a:bodyPr>
+          <a:lstStyle/>
+          <a:p>
+            <a:pPr algn="l"/>
+            <a:r>
+              <a:rPr sz="900" b="0" i="0">
+                <a:solidFill>
+                  <a:srgbClr val="6B7480"/>
+                </a:solidFill>
+                <a:latin typeface="Calibri"/>
+              </a:rPr>
+              <a:t>Job Application Agent</a:t>
+            </a:r>
+          </a:p>
+        </p:txBody>
+      </p:sp>
+      <p:sp>
+        <p:nvSpPr>
+          <p:cNvPr id="11" name="TextBox 11"/>
+          <p:cNvSpPr txBox="1"/>
+          <p:nvPr/>
+        </p:nvSpPr>
+        <p:spPr>
+          <a:xfrm>
+            <a:off x="11338560" y="6537960"/>
+            <a:ext cx="457200" cy="274320"/>
+          </a:xfrm>
+          <a:prstGeom prst="rect">
+            <a:avLst/>
+          </a:prstGeom>
+          <a:noFill/>
+        </p:spPr>
+        <p:txBody>
+          <a:bodyPr wrap="square">
+            <a:spAutoFit/>
+          </a:bodyPr>
+          <a:lstStyle/>
+          <a:p>
+            <a:pPr algn="r"/>
+            <a:r>
+              <a:rPr sz="900" b="0" i="0">
+                <a:solidFill>
+                  <a:srgbClr val="6B7480"/>
+                </a:solidFill>
+                <a:latin typeface="Calibri"/>
+              </a:rPr>
+              <a:t>13</a:t>
+            </a:r>
+          </a:p>
+        </p:txBody>
+      </p:sp>
+    </p:spTree>
+  </p:cSld>
+  <p:clrMapOvr>
+    <a:masterClrMapping/>
+  </p:clrMapOvr>
+</p:sld>
+</file>
+
+<file path=ppt/slides/slide18.xml><?xml version="1.0" encoding="utf-8"?>
+<p:sld xmlns:a="http://schemas.openxmlformats.org/drawingml/2006/main" xmlns:p="http://schemas.openxmlformats.org/presentationml/2006/main" xmlns:r="http://schemas.openxmlformats.org/officeDocument/2006/relationships">
+  <p:cSld>
+    <p:bg>
+      <p:bgPr>
+        <a:solidFill>
+          <a:srgbClr val="FFFFFF"/>
+        </a:solidFill>
+        <a:effectLst/>
+      </p:bgPr>
+    </p:bg>
+    <p:spTree>
+      <p:nvGrpSpPr>
+        <p:cNvPr id="1" name=""/>
+        <p:cNvGrpSpPr/>
+        <p:nvPr/>
+      </p:nvGrpSpPr>
+      <p:grpSpPr/>
+      <p:sp>
+        <p:nvSpPr>
+          <p:cNvPr id="2" name="Rectangle 1"/>
+          <p:cNvSpPr/>
+          <p:nvPr/>
+        </p:nvSpPr>
+        <p:spPr>
+          <a:xfrm>
+            <a:off x="0" y="0"/>
+            <a:ext cx="12191695" cy="109728"/>
+          </a:xfrm>
+          <a:prstGeom prst="rect">
+            <a:avLst/>
+          </a:prstGeom>
+          <a:solidFill>
+            <a:srgbClr val="2B6CB0"/>
+          </a:solidFill>
+          <a:ln>
+            <a:noFill/>
+          </a:ln>
+          <a:effectLst/>
+        </p:spPr>
+        <p:style>
+          <a:lnRef idx="1">
+            <a:schemeClr val="accent1"/>
+          </a:lnRef>
+          <a:fillRef idx="3">
+            <a:schemeClr val="accent1"/>
+          </a:fillRef>
+          <a:effectRef idx="2">
+            <a:schemeClr val="accent1"/>
+          </a:effectRef>
+          <a:fontRef idx="minor">
+            <a:schemeClr val="lt1"/>
+          </a:fontRef>
+        </p:style>
+        <p:txBody>
+          <a:bodyPr rtlCol="0" anchor="ctr"/>
+          <a:lstStyle/>
+          <a:p>
+            <a:pPr algn="ctr"/>
+          </a:p>
+        </p:txBody>
+      </p:sp>
+      <p:sp>
+        <p:nvSpPr>
+          <p:cNvPr id="3" name="TextBox 2"/>
+          <p:cNvSpPr txBox="1"/>
+          <p:nvPr/>
+        </p:nvSpPr>
+        <p:spPr>
+          <a:xfrm>
+            <a:off x="502920" y="256032"/>
+            <a:ext cx="10058400" cy="320040"/>
+          </a:xfrm>
+          <a:prstGeom prst="rect">
+            <a:avLst/>
+          </a:prstGeom>
+          <a:noFill/>
+        </p:spPr>
+        <p:txBody>
+          <a:bodyPr wrap="square">
+            <a:spAutoFit/>
+          </a:bodyPr>
+          <a:lstStyle/>
+          <a:p>
+            <a:pPr algn="l"/>
+            <a:r>
+              <a:rPr sz="1300" b="1" i="0">
+                <a:solidFill>
+                  <a:srgbClr val="2B6CB0"/>
+                </a:solidFill>
+                <a:latin typeface="Calibri"/>
+              </a:rPr>
+              <a:t>PERSISTENT PER-APPLICATION RECORDS</a:t>
+            </a:r>
+          </a:p>
+        </p:txBody>
+      </p:sp>
+      <p:sp>
+        <p:nvSpPr>
+          <p:cNvPr id="4" name="TextBox 3"/>
+          <p:cNvSpPr txBox="1"/>
+          <p:nvPr/>
+        </p:nvSpPr>
+        <p:spPr>
+          <a:xfrm>
+            <a:off x="502920" y="548640"/>
+            <a:ext cx="11155680" cy="640080"/>
+          </a:xfrm>
+          <a:prstGeom prst="rect">
+            <a:avLst/>
+          </a:prstGeom>
+          <a:noFill/>
+        </p:spPr>
+        <p:txBody>
+          <a:bodyPr wrap="square">
+            <a:spAutoFit/>
+          </a:bodyPr>
+          <a:lstStyle/>
+          <a:p>
+            <a:pPr algn="l"/>
+            <a:r>
+              <a:rPr sz="2800" b="1" i="0">
+                <a:solidFill>
+                  <a:srgbClr val="1A2E4A"/>
+                </a:solidFill>
+                <a:latin typeface="Calibri"/>
+              </a:rPr>
+              <a:t>Every Tailored CV Gets Its Own History</a:t>
+            </a:r>
+          </a:p>
+        </p:txBody>
+      </p:sp>
+      <p:sp>
+        <p:nvSpPr>
+          <p:cNvPr id="5" name="Rectangle 4"/>
+          <p:cNvSpPr/>
+          <p:nvPr/>
+        </p:nvSpPr>
+        <p:spPr>
+          <a:xfrm>
+            <a:off x="521207" y="1170432"/>
+            <a:ext cx="1463040" cy="38100"/>
+          </a:xfrm>
+          <a:prstGeom prst="rect">
+            <a:avLst/>
+          </a:prstGeom>
+          <a:solidFill>
+            <a:srgbClr val="2B6CB0"/>
+          </a:solidFill>
+          <a:ln>
+            <a:noFill/>
+          </a:ln>
+          <a:effectLst/>
+        </p:spPr>
+        <p:style>
+          <a:lnRef idx="1">
+            <a:schemeClr val="accent1"/>
+          </a:lnRef>
+          <a:fillRef idx="3">
+            <a:schemeClr val="accent1"/>
+          </a:fillRef>
+          <a:effectRef idx="2">
+            <a:schemeClr val="accent1"/>
+          </a:effectRef>
+          <a:fontRef idx="minor">
+            <a:schemeClr val="lt1"/>
+          </a:fontRef>
+        </p:style>
+        <p:txBody>
+          <a:bodyPr rtlCol="0" anchor="ctr"/>
+          <a:lstStyle/>
+          <a:p>
+            <a:pPr algn="ctr"/>
+          </a:p>
+        </p:txBody>
+      </p:sp>
+      <p:sp>
+        <p:nvSpPr>
+          <p:cNvPr id="6" name="TextBox 5"/>
+          <p:cNvSpPr txBox="1"/>
+          <p:nvPr/>
+        </p:nvSpPr>
+        <p:spPr>
+          <a:xfrm>
+            <a:off x="640080" y="1554480"/>
+            <a:ext cx="10789920" cy="4572000"/>
+          </a:xfrm>
+          <a:prstGeom prst="rect">
+            <a:avLst/>
+          </a:prstGeom>
+          <a:noFill/>
+        </p:spPr>
+        <p:txBody>
+          <a:bodyPr wrap="square">
+            <a:spAutoFit/>
+          </a:bodyPr>
+          <a:lstStyle/>
+          <a:p>
+            <a:pPr>
+              <a:spcAft>
+                <a:spcPts val="1800"/>
+              </a:spcAft>
+            </a:pPr>
+            <a:r>
+              <a:rPr b="1" sz="1700">
+                <a:solidFill>
+                  <a:srgbClr val="1A2E4A"/>
+                </a:solidFill>
+                <a:latin typeface="Calibri"/>
+              </a:rPr>
+              <a:t>▪  A new row every time</a:t>
+            </a:r>
+            <a:r>
+              <a:rPr sz="1600">
+                <a:solidFill>
+                  <a:srgbClr val="3D4754"/>
+                </a:solidFill>
+                <a:latin typeface="Calibri"/>
+              </a:rPr>
+              <a:t>  — company, role, the complete tailored CV text, and a timestamp</a:t>
+            </a:r>
+          </a:p>
+          <a:p>
+            <a:pPr>
+              <a:spcAft>
+                <a:spcPts val="1800"/>
+              </a:spcAft>
+            </a:pPr>
+            <a:r>
+              <a:rPr b="1" sz="1700">
+                <a:solidFill>
+                  <a:srgbClr val="1A2E4A"/>
+                </a:solidFill>
+                <a:latin typeface="Calibri"/>
+              </a:rPr>
+              <a:t>▪  Never an update, always an insert</a:t>
+            </a:r>
+            <a:r>
+              <a:rPr sz="1600">
+                <a:solidFill>
+                  <a:srgbClr val="3D4754"/>
+                </a:solidFill>
+                <a:latin typeface="Calibri"/>
+              </a:rPr>
+              <a:t>  — a second application to the same company adds a second version</a:t>
+            </a:r>
+          </a:p>
+          <a:p>
+            <a:pPr>
+              <a:spcAft>
+                <a:spcPts val="1800"/>
+              </a:spcAft>
+            </a:pPr>
+            <a:r>
+              <a:rPr b="1" sz="1700">
+                <a:solidFill>
+                  <a:srgbClr val="1A2E4A"/>
+                </a:solidFill>
+                <a:latin typeface="Calibri"/>
+              </a:rPr>
+              <a:t>▪  Tailoring reads the baseline, never writes to it</a:t>
+            </a:r>
+            <a:r>
+              <a:rPr sz="1600">
+                <a:solidFill>
+                  <a:srgbClr val="3D4754"/>
+                </a:solidFill>
+                <a:latin typeface="Calibri"/>
+              </a:rPr>
+              <a:t>  — the guarantee holds by construction, not by convention</a:t>
+            </a:r>
+          </a:p>
+          <a:p>
+            <a:pPr>
+              <a:spcAft>
+                <a:spcPts val="1800"/>
+              </a:spcAft>
+            </a:pPr>
+            <a:r>
+              <a:rPr b="1" sz="1700">
+                <a:solidFill>
+                  <a:srgbClr val="1A2E4A"/>
+                </a:solidFill>
+                <a:latin typeface="Calibri"/>
+              </a:rPr>
+              <a:t>▪  Sephora and Nexus, kept completely separate</a:t>
+            </a:r>
+            <a:r>
+              <a:rPr sz="1600">
+                <a:solidFill>
+                  <a:srgbClr val="3D4754"/>
+                </a:solidFill>
+                <a:latin typeface="Calibri"/>
+              </a:rPr>
+              <a:t>  — every company gets its own row, never merged or overwritten</a:t>
+            </a:r>
+          </a:p>
+          <a:p>
+            <a:pPr>
+              <a:spcAft>
+                <a:spcPts val="1800"/>
+              </a:spcAft>
+            </a:pPr>
+            <a:r>
+              <a:rPr b="1" sz="1700">
+                <a:solidFill>
+                  <a:srgbClr val="1A2E4A"/>
+                </a:solidFill>
+                <a:latin typeface="Calibri"/>
+              </a:rPr>
+              <a:t>▪  Visible in the UI as “My Tailored CVs”</a:t>
+            </a:r>
+            <a:r>
+              <a:rPr sz="1600">
+                <a:solidFill>
+                  <a:srgbClr val="3D4754"/>
+                </a:solidFill>
+                <a:latin typeface="Calibri"/>
+              </a:rPr>
+              <a:t>  — grouped by company, each one downloadable</a:t>
+            </a:r>
+          </a:p>
+          <a:p>
+            <a:pPr>
+              <a:spcAft>
+                <a:spcPts val="1800"/>
+              </a:spcAft>
+            </a:pPr>
+            <a:r>
+              <a:rPr b="1" sz="1700">
+                <a:solidFill>
+                  <a:srgbClr val="1A2E4A"/>
+                </a:solidFill>
+                <a:latin typeface="Calibri"/>
+              </a:rPr>
+              <a:t>▪  Still tied to the account that created it</a:t>
+            </a:r>
+            <a:r>
+              <a:rPr sz="1600">
+                <a:solidFill>
+                  <a:srgbClr val="3D4754"/>
+                </a:solidFill>
+                <a:latin typeface="Calibri"/>
+              </a:rPr>
+              <a:t>  — one user’s tailored CVs are never visible to another</a:t>
+            </a:r>
+          </a:p>
+        </p:txBody>
+      </p:sp>
+      <p:sp>
+        <p:nvSpPr>
+          <p:cNvPr id="7" name="TextBox 7"/>
+          <p:cNvSpPr txBox="1"/>
+          <p:nvPr/>
+        </p:nvSpPr>
+        <p:spPr>
+          <a:xfrm>
+            <a:off x="502920" y="6537960"/>
+            <a:ext cx="5486400" cy="274320"/>
+          </a:xfrm>
+          <a:prstGeom prst="rect">
+            <a:avLst/>
+          </a:prstGeom>
+          <a:noFill/>
+        </p:spPr>
+        <p:txBody>
+          <a:bodyPr wrap="square">
+            <a:spAutoFit/>
+          </a:bodyPr>
+          <a:lstStyle/>
+          <a:p>
+            <a:pPr algn="l"/>
+            <a:r>
+              <a:rPr sz="900" b="0" i="0">
+                <a:solidFill>
+                  <a:srgbClr val="6B7480"/>
+                </a:solidFill>
+                <a:latin typeface="Calibri"/>
+              </a:rPr>
+              <a:t>Job Application Agent</a:t>
+            </a:r>
+          </a:p>
+        </p:txBody>
+      </p:sp>
+      <p:sp>
+        <p:nvSpPr>
+          <p:cNvPr id="8" name="TextBox 8"/>
+          <p:cNvSpPr txBox="1"/>
+          <p:nvPr/>
+        </p:nvSpPr>
+        <p:spPr>
+          <a:xfrm>
+            <a:off x="11338560" y="6537960"/>
+            <a:ext cx="457200" cy="274320"/>
+          </a:xfrm>
+          <a:prstGeom prst="rect">
+            <a:avLst/>
+          </a:prstGeom>
+          <a:noFill/>
+        </p:spPr>
+        <p:txBody>
+          <a:bodyPr wrap="square">
+            <a:spAutoFit/>
+          </a:bodyPr>
+          <a:lstStyle/>
+          <a:p>
+            <a:pPr algn="r"/>
+            <a:r>
+              <a:rPr sz="900" b="0" i="0">
+                <a:solidFill>
+                  <a:srgbClr val="6B7480"/>
+                </a:solidFill>
+                <a:latin typeface="Calibri"/>
+              </a:rPr>
+              <a:t>14</a:t>
+            </a:r>
+          </a:p>
+        </p:txBody>
+      </p:sp>
+    </p:spTree>
+  </p:cSld>
+  <p:clrMapOvr>
+    <a:masterClrMapping/>
+  </p:clrMapOvr>
+</p:sld>
+</file>
+
+<file path=ppt/slides/slide19.xml><?xml version="1.0" encoding="utf-8"?>
+<p:sld xmlns:a="http://schemas.openxmlformats.org/drawingml/2006/main" xmlns:p="http://schemas.openxmlformats.org/presentationml/2006/main" xmlns:r="http://schemas.openxmlformats.org/officeDocument/2006/relationships">
+  <p:cSld>
+    <p:bg>
+      <p:bgPr>
+        <a:solidFill>
+          <a:srgbClr val="FFFFFF"/>
+        </a:solidFill>
+        <a:effectLst/>
+      </p:bgPr>
+    </p:bg>
+    <p:spTree>
+      <p:nvGrpSpPr>
+        <p:cNvPr id="1" name=""/>
+        <p:cNvGrpSpPr/>
+        <p:nvPr/>
+      </p:nvGrpSpPr>
+      <p:grpSpPr/>
+      <p:sp>
+        <p:nvSpPr>
+          <p:cNvPr id="2" name="Rectangle 1"/>
+          <p:cNvSpPr/>
+          <p:nvPr/>
+        </p:nvSpPr>
+        <p:spPr>
+          <a:xfrm>
+            <a:off x="0" y="0"/>
+            <a:ext cx="12191695" cy="109728"/>
+          </a:xfrm>
+          <a:prstGeom prst="rect">
+            <a:avLst/>
+          </a:prstGeom>
+          <a:solidFill>
+            <a:srgbClr val="2B6CB0"/>
+          </a:solidFill>
+          <a:ln>
+            <a:noFill/>
+          </a:ln>
+          <a:effectLst/>
+        </p:spPr>
+        <p:style>
+          <a:lnRef idx="1">
+            <a:schemeClr val="accent1"/>
+          </a:lnRef>
+          <a:fillRef idx="3">
+            <a:schemeClr val="accent1"/>
+          </a:fillRef>
+          <a:effectRef idx="2">
+            <a:schemeClr val="accent1"/>
+          </a:effectRef>
+          <a:fontRef idx="minor">
+            <a:schemeClr val="lt1"/>
+          </a:fontRef>
+        </p:style>
+        <p:txBody>
+          <a:bodyPr rtlCol="0" anchor="ctr"/>
+          <a:lstStyle/>
+          <a:p>
+            <a:pPr algn="ctr"/>
+          </a:p>
+        </p:txBody>
+      </p:sp>
+      <p:sp>
+        <p:nvSpPr>
+          <p:cNvPr id="3" name="TextBox 2"/>
+          <p:cNvSpPr txBox="1"/>
+          <p:nvPr/>
+        </p:nvSpPr>
+        <p:spPr>
+          <a:xfrm>
+            <a:off x="502920" y="256032"/>
+            <a:ext cx="10058400" cy="320040"/>
+          </a:xfrm>
+          <a:prstGeom prst="rect">
+            <a:avLst/>
+          </a:prstGeom>
+          <a:noFill/>
+        </p:spPr>
+        <p:txBody>
+          <a:bodyPr wrap="square">
+            <a:spAutoFit/>
+          </a:bodyPr>
+          <a:lstStyle/>
+          <a:p>
+            <a:pPr algn="l"/>
+            <a:r>
+              <a:rPr sz="1300" b="1" i="0">
+                <a:solidFill>
+                  <a:srgbClr val="2B6CB0"/>
+                </a:solidFill>
+                <a:latin typeface="Calibri"/>
+              </a:rPr>
+              <a:t>EASIER TO READ, CHEAPER TO PRODUCE</a:t>
+            </a:r>
+          </a:p>
+        </p:txBody>
+      </p:sp>
+      <p:sp>
+        <p:nvSpPr>
+          <p:cNvPr id="4" name="TextBox 3"/>
+          <p:cNvSpPr txBox="1"/>
+          <p:nvPr/>
+        </p:nvSpPr>
+        <p:spPr>
+          <a:xfrm>
+            <a:off x="502920" y="548640"/>
+            <a:ext cx="11155680" cy="640080"/>
+          </a:xfrm>
+          <a:prstGeom prst="rect">
+            <a:avLst/>
+          </a:prstGeom>
+          <a:noFill/>
+        </p:spPr>
+        <p:txBody>
+          <a:bodyPr wrap="square">
+            <a:spAutoFit/>
+          </a:bodyPr>
+          <a:lstStyle/>
+          <a:p>
+            <a:pPr algn="l"/>
+            <a:r>
+              <a:rPr sz="2800" b="1" i="0">
+                <a:solidFill>
+                  <a:srgbClr val="1A2E4A"/>
+                </a:solidFill>
+                <a:latin typeface="Calibri"/>
+              </a:rPr>
+              <a:t>Visual Summary &amp; Company Research Caching</a:t>
+            </a:r>
+          </a:p>
+        </p:txBody>
+      </p:sp>
+      <p:sp>
+        <p:nvSpPr>
+          <p:cNvPr id="5" name="Rectangle 4"/>
+          <p:cNvSpPr/>
+          <p:nvPr/>
+        </p:nvSpPr>
+        <p:spPr>
+          <a:xfrm>
+            <a:off x="521207" y="1170432"/>
+            <a:ext cx="1463040" cy="38100"/>
+          </a:xfrm>
+          <a:prstGeom prst="rect">
+            <a:avLst/>
+          </a:prstGeom>
+          <a:solidFill>
+            <a:srgbClr val="2B6CB0"/>
+          </a:solidFill>
+          <a:ln>
+            <a:noFill/>
+          </a:ln>
+          <a:effectLst/>
+        </p:spPr>
+        <p:style>
+          <a:lnRef idx="1">
+            <a:schemeClr val="accent1"/>
+          </a:lnRef>
+          <a:fillRef idx="3">
+            <a:schemeClr val="accent1"/>
+          </a:fillRef>
+          <a:effectRef idx="2">
+            <a:schemeClr val="accent1"/>
+          </a:effectRef>
+          <a:fontRef idx="minor">
+            <a:schemeClr val="lt1"/>
+          </a:fontRef>
+        </p:style>
+        <p:txBody>
+          <a:bodyPr rtlCol="0" anchor="ctr"/>
+          <a:lstStyle/>
+          <a:p>
+            <a:pPr algn="ctr"/>
+          </a:p>
+        </p:txBody>
+      </p:sp>
+      <p:sp>
+        <p:nvSpPr>
+          <p:cNvPr id="6" name="Rounded Rectangle 5"/>
+          <p:cNvSpPr/>
+          <p:nvPr/>
+        </p:nvSpPr>
+        <p:spPr>
+          <a:xfrm>
+            <a:off x="640080" y="1463040"/>
+            <a:ext cx="5212080" cy="457200"/>
+          </a:xfrm>
+          <a:prstGeom prst="roundRect">
+            <a:avLst/>
+          </a:prstGeom>
+          <a:solidFill>
+            <a:srgbClr val="E9F2FB"/>
+          </a:solidFill>
+          <a:ln w="15875">
+            <a:solidFill>
+              <a:srgbClr val="2B6CB0"/>
+            </a:solidFill>
+          </a:ln>
+          <a:effectLst/>
+        </p:spPr>
+        <p:style>
+          <a:lnRef idx="1">
+            <a:schemeClr val="accent1"/>
+          </a:lnRef>
+          <a:fillRef idx="3">
+            <a:schemeClr val="accent1"/>
+          </a:fillRef>
+          <a:effectRef idx="2">
+            <a:schemeClr val="accent1"/>
+          </a:effectRef>
+          <a:fontRef idx="minor">
+            <a:schemeClr val="lt1"/>
+          </a:fontRef>
+        </p:style>
+        <p:txBody>
+          <a:bodyPr rtlCol="0" anchor="ctr" wrap="square" lIns="50800" rIns="50800" tIns="25400" bIns="25400"/>
+          <a:lstStyle/>
+          <a:p>
+            <a:pPr algn="ctr"/>
+            <a:r>
+              <a:rPr sz="1400" b="1" i="0">
+                <a:solidFill>
+                  <a:srgbClr val="1F4E82"/>
+                </a:solidFill>
+                <a:latin typeface="Calibri"/>
+              </a:rPr>
+              <a:t>RESULTS DASHBOARD</a:t>
+            </a:r>
+          </a:p>
+        </p:txBody>
+      </p:sp>
+      <p:sp>
+        <p:nvSpPr>
+          <p:cNvPr id="7" name="TextBox 6"/>
+          <p:cNvSpPr txBox="1"/>
+          <p:nvPr/>
+        </p:nvSpPr>
+        <p:spPr>
+          <a:xfrm>
+            <a:off x="640080" y="2057400"/>
+            <a:ext cx="5212080" cy="3931920"/>
+          </a:xfrm>
+          <a:prstGeom prst="rect">
+            <a:avLst/>
+          </a:prstGeom>
+          <a:noFill/>
+        </p:spPr>
+        <p:txBody>
+          <a:bodyPr wrap="square">
+            <a:spAutoFit/>
+          </a:bodyPr>
+          <a:lstStyle/>
+          <a:p>
+            <a:pPr>
+              <a:spcAft>
+                <a:spcPts val="1600"/>
+              </a:spcAft>
+            </a:pPr>
+            <a:r>
+              <a:rPr sz="1600">
+                <a:solidFill>
+                  <a:srgbClr val="3D4754"/>
+                </a:solidFill>
+                <a:latin typeface="Calibri"/>
+              </a:rPr>
+              <a:t>▪  Overall fit score, shown prominently</a:t>
+            </a:r>
+          </a:p>
+          <a:p>
+            <a:pPr>
+              <a:spcAft>
+                <a:spcPts val="1600"/>
+              </a:spcAft>
+            </a:pPr>
+            <a:r>
+              <a:rPr sz="1600">
+                <a:solidFill>
+                  <a:srgbClr val="3D4754"/>
+                </a:solidFill>
+                <a:latin typeface="Calibri"/>
+              </a:rPr>
+              <a:t>▪  A chart of MATCH / PARTIAL / RELATED / MISSING counts</a:t>
+            </a:r>
+          </a:p>
+          <a:p>
+            <a:pPr>
+              <a:spcAft>
+                <a:spcPts val="1600"/>
+              </a:spcAft>
+            </a:pPr>
+            <a:r>
+              <a:rPr sz="1600">
+                <a:solidFill>
+                  <a:srgbClr val="3D4754"/>
+                </a:solidFill>
+                <a:latin typeface="Calibri"/>
+              </a:rPr>
+              <a:t>▪  Must-have vs. nice-to-have performance, side by side</a:t>
+            </a:r>
+          </a:p>
+          <a:p>
+            <a:pPr>
+              <a:spcAft>
+                <a:spcPts val="1600"/>
+              </a:spcAft>
+            </a:pPr>
+            <a:r>
+              <a:rPr sz="1600">
+                <a:solidFill>
+                  <a:srgbClr val="3D4754"/>
+                </a:solidFill>
+                <a:latin typeface="Calibri"/>
+              </a:rPr>
+              <a:t>▪  Computed with plain Python — no new model call</a:t>
+            </a:r>
+          </a:p>
+        </p:txBody>
+      </p:sp>
+      <p:sp>
+        <p:nvSpPr>
+          <p:cNvPr id="8" name="Rounded Rectangle 7"/>
+          <p:cNvSpPr/>
+          <p:nvPr/>
+        </p:nvSpPr>
+        <p:spPr>
+          <a:xfrm>
+            <a:off x="6217920" y="1463040"/>
+            <a:ext cx="5303520" cy="457200"/>
+          </a:xfrm>
+          <a:prstGeom prst="roundRect">
+            <a:avLst/>
+          </a:prstGeom>
+          <a:solidFill>
+            <a:srgbClr val="E7F5EE"/>
+          </a:solidFill>
+          <a:ln w="15875">
+            <a:solidFill>
+              <a:srgbClr val="2F7D5C"/>
+            </a:solidFill>
+          </a:ln>
+          <a:effectLst/>
+        </p:spPr>
+        <p:style>
+          <a:lnRef idx="1">
+            <a:schemeClr val="accent1"/>
+          </a:lnRef>
+          <a:fillRef idx="3">
+            <a:schemeClr val="accent1"/>
+          </a:fillRef>
+          <a:effectRef idx="2">
+            <a:schemeClr val="accent1"/>
+          </a:effectRef>
+          <a:fontRef idx="minor">
+            <a:schemeClr val="lt1"/>
+          </a:fontRef>
+        </p:style>
+        <p:txBody>
+          <a:bodyPr rtlCol="0" anchor="ctr" wrap="square" lIns="50800" rIns="50800" tIns="25400" bIns="25400"/>
+          <a:lstStyle/>
+          <a:p>
+            <a:pPr algn="ctr"/>
+            <a:r>
+              <a:rPr sz="1400" b="1" i="0">
+                <a:solidFill>
+                  <a:srgbClr val="2F7D5C"/>
+                </a:solidFill>
+                <a:latin typeface="Calibri"/>
+              </a:rPr>
+              <a:t>COMPANY RESEARCH CACHE</a:t>
+            </a:r>
+          </a:p>
+        </p:txBody>
+      </p:sp>
+      <p:sp>
+        <p:nvSpPr>
+          <p:cNvPr id="9" name="TextBox 8"/>
+          <p:cNvSpPr txBox="1"/>
+          <p:nvPr/>
+        </p:nvSpPr>
+        <p:spPr>
+          <a:xfrm>
+            <a:off x="6217920" y="2057400"/>
+            <a:ext cx="5303520" cy="3931920"/>
+          </a:xfrm>
+          <a:prstGeom prst="rect">
+            <a:avLst/>
+          </a:prstGeom>
+          <a:noFill/>
+        </p:spPr>
+        <p:txBody>
+          <a:bodyPr wrap="square">
+            <a:spAutoFit/>
+          </a:bodyPr>
+          <a:lstStyle/>
+          <a:p>
+            <a:pPr>
+              <a:spcAft>
+                <a:spcPts val="1600"/>
+              </a:spcAft>
+            </a:pPr>
+            <a:r>
+              <a:rPr sz="1600">
+                <a:solidFill>
+                  <a:srgbClr val="3D4754"/>
+                </a:solidFill>
+                <a:latin typeface="Calibri"/>
+              </a:rPr>
+              <a:t>▪  Same company looked up again → the cached brief is reused</a:t>
+            </a:r>
+          </a:p>
+          <a:p>
+            <a:pPr>
+              <a:spcAft>
+                <a:spcPts val="1600"/>
+              </a:spcAft>
+            </a:pPr>
+            <a:r>
+              <a:rPr sz="1600">
+                <a:solidFill>
+                  <a:srgbClr val="3D4754"/>
+                </a:solidFill>
+                <a:latin typeface="Calibri"/>
+              </a:rPr>
+              <a:t>▪  A configurable time-to-live, not a fixed guess</a:t>
+            </a:r>
+          </a:p>
+          <a:p>
+            <a:pPr>
+              <a:spcAft>
+                <a:spcPts val="1600"/>
+              </a:spcAft>
+            </a:pPr>
+            <a:r>
+              <a:rPr sz="1600">
+                <a:solidFill>
+                  <a:srgbClr val="3D4754"/>
+                </a:solidFill>
+                <a:latin typeface="Calibri"/>
+              </a:rPr>
+              <a:t>▪  Skips both the search call and the summary call on a hit</a:t>
+            </a:r>
+          </a:p>
+          <a:p>
+            <a:pPr>
+              <a:spcAft>
+                <a:spcPts val="1600"/>
+              </a:spcAft>
+            </a:pPr>
+            <a:r>
+              <a:rPr sz="1600">
+                <a:solidFill>
+                  <a:srgbClr val="3D4754"/>
+                </a:solidFill>
+                <a:latin typeface="Calibri"/>
+              </a:rPr>
+              <a:t>▪  A failed or sourceless lookup is never cached</a:t>
+            </a:r>
+          </a:p>
+        </p:txBody>
+      </p:sp>
+      <p:sp>
+        <p:nvSpPr>
+          <p:cNvPr id="10" name="TextBox 10"/>
+          <p:cNvSpPr txBox="1"/>
+          <p:nvPr/>
+        </p:nvSpPr>
+        <p:spPr>
+          <a:xfrm>
+            <a:off x="502920" y="6537960"/>
+            <a:ext cx="5486400" cy="274320"/>
+          </a:xfrm>
+          <a:prstGeom prst="rect">
+            <a:avLst/>
+          </a:prstGeom>
+          <a:noFill/>
+        </p:spPr>
+        <p:txBody>
+          <a:bodyPr wrap="square">
+            <a:spAutoFit/>
+          </a:bodyPr>
+          <a:lstStyle/>
+          <a:p>
+            <a:pPr algn="l"/>
+            <a:r>
+              <a:rPr sz="900" b="0" i="0">
+                <a:solidFill>
+                  <a:srgbClr val="6B7480"/>
+                </a:solidFill>
+                <a:latin typeface="Calibri"/>
+              </a:rPr>
+              <a:t>Job Application Agent</a:t>
+            </a:r>
+          </a:p>
+        </p:txBody>
+      </p:sp>
+      <p:sp>
+        <p:nvSpPr>
+          <p:cNvPr id="11" name="TextBox 11"/>
+          <p:cNvSpPr txBox="1"/>
+          <p:nvPr/>
+        </p:nvSpPr>
+        <p:spPr>
+          <a:xfrm>
+            <a:off x="11338560" y="6537960"/>
+            <a:ext cx="457200" cy="274320"/>
+          </a:xfrm>
+          <a:prstGeom prst="rect">
+            <a:avLst/>
+          </a:prstGeom>
+          <a:noFill/>
+        </p:spPr>
+        <p:txBody>
+          <a:bodyPr wrap="square">
+            <a:spAutoFit/>
+          </a:bodyPr>
+          <a:lstStyle/>
+          <a:p>
+            <a:pPr algn="r"/>
+            <a:r>
+              <a:rPr sz="900" b="0" i="0">
+                <a:solidFill>
+                  <a:srgbClr val="6B7480"/>
+                </a:solidFill>
+                <a:latin typeface="Calibri"/>
+              </a:rPr>
+              <a:t>15</a:t>
             </a:r>
           </a:p>
         </p:txBody>
@@ -11115,6 +12622,544 @@
                 <a:latin typeface="Calibri"/>
               </a:rPr>
               <a:t>  — tempting to round “basic knowledge” up to “experience”</a:t>
+            </a:r>
+          </a:p>
+        </p:txBody>
+      </p:sp>
+    </p:spTree>
+  </p:cSld>
+  <p:clrMapOvr>
+    <a:masterClrMapping/>
+  </p:clrMapOvr>
+</p:sld>
+</file>
+
+<file path=ppt/slides/slide20.xml><?xml version="1.0" encoding="utf-8"?>
+<p:sld xmlns:a="http://schemas.openxmlformats.org/drawingml/2006/main" xmlns:p="http://schemas.openxmlformats.org/presentationml/2006/main" xmlns:r="http://schemas.openxmlformats.org/officeDocument/2006/relationships">
+  <p:cSld>
+    <p:bg>
+      <p:bgPr>
+        <a:solidFill>
+          <a:srgbClr val="FFFFFF"/>
+        </a:solidFill>
+        <a:effectLst/>
+      </p:bgPr>
+    </p:bg>
+    <p:spTree>
+      <p:nvGrpSpPr>
+        <p:cNvPr id="1" name=""/>
+        <p:cNvGrpSpPr/>
+        <p:nvPr/>
+      </p:nvGrpSpPr>
+      <p:grpSpPr/>
+      <p:sp>
+        <p:nvSpPr>
+          <p:cNvPr id="2" name="Rectangle 1"/>
+          <p:cNvSpPr/>
+          <p:nvPr/>
+        </p:nvSpPr>
+        <p:spPr>
+          <a:xfrm>
+            <a:off x="0" y="0"/>
+            <a:ext cx="12191695" cy="109728"/>
+          </a:xfrm>
+          <a:prstGeom prst="rect">
+            <a:avLst/>
+          </a:prstGeom>
+          <a:solidFill>
+            <a:srgbClr val="2B6CB0"/>
+          </a:solidFill>
+          <a:ln>
+            <a:noFill/>
+          </a:ln>
+          <a:effectLst/>
+        </p:spPr>
+        <p:style>
+          <a:lnRef idx="1">
+            <a:schemeClr val="accent1"/>
+          </a:lnRef>
+          <a:fillRef idx="3">
+            <a:schemeClr val="accent1"/>
+          </a:fillRef>
+          <a:effectRef idx="2">
+            <a:schemeClr val="accent1"/>
+          </a:effectRef>
+          <a:fontRef idx="minor">
+            <a:schemeClr val="lt1"/>
+          </a:fontRef>
+        </p:style>
+        <p:txBody>
+          <a:bodyPr rtlCol="0" anchor="ctr"/>
+          <a:lstStyle/>
+          <a:p>
+            <a:pPr algn="ctr"/>
+          </a:p>
+        </p:txBody>
+      </p:sp>
+      <p:sp>
+        <p:nvSpPr>
+          <p:cNvPr id="3" name="TextBox 2"/>
+          <p:cNvSpPr txBox="1"/>
+          <p:nvPr/>
+        </p:nvSpPr>
+        <p:spPr>
+          <a:xfrm>
+            <a:off x="502920" y="256032"/>
+            <a:ext cx="10058400" cy="320040"/>
+          </a:xfrm>
+          <a:prstGeom prst="rect">
+            <a:avLst/>
+          </a:prstGeom>
+          <a:noFill/>
+        </p:spPr>
+        <p:txBody>
+          <a:bodyPr wrap="square">
+            <a:spAutoFit/>
+          </a:bodyPr>
+          <a:lstStyle/>
+          <a:p>
+            <a:pPr algn="l"/>
+            <a:r>
+              <a:rPr sz="1300" b="1" i="0">
+                <a:solidFill>
+                  <a:srgbClr val="2B6CB0"/>
+                </a:solidFill>
+                <a:latin typeface="Calibri"/>
+              </a:rPr>
+              <a:t>RUNNING IT ANYWHERE, ON ANY PROVIDER</a:t>
+            </a:r>
+          </a:p>
+        </p:txBody>
+      </p:sp>
+      <p:sp>
+        <p:nvSpPr>
+          <p:cNvPr id="4" name="TextBox 3"/>
+          <p:cNvSpPr txBox="1"/>
+          <p:nvPr/>
+        </p:nvSpPr>
+        <p:spPr>
+          <a:xfrm>
+            <a:off x="502920" y="548640"/>
+            <a:ext cx="11155680" cy="640080"/>
+          </a:xfrm>
+          <a:prstGeom prst="rect">
+            <a:avLst/>
+          </a:prstGeom>
+          <a:noFill/>
+        </p:spPr>
+        <p:txBody>
+          <a:bodyPr wrap="square">
+            <a:spAutoFit/>
+          </a:bodyPr>
+          <a:lstStyle/>
+          <a:p>
+            <a:pPr algn="l"/>
+            <a:r>
+              <a:rPr sz="2800" b="1" i="0">
+                <a:solidFill>
+                  <a:srgbClr val="1A2E4A"/>
+                </a:solidFill>
+                <a:latin typeface="Calibri"/>
+              </a:rPr>
+              <a:t>Docker Compose &amp; Verified Alternative Providers</a:t>
+            </a:r>
+          </a:p>
+        </p:txBody>
+      </p:sp>
+      <p:sp>
+        <p:nvSpPr>
+          <p:cNvPr id="5" name="Rectangle 4"/>
+          <p:cNvSpPr/>
+          <p:nvPr/>
+        </p:nvSpPr>
+        <p:spPr>
+          <a:xfrm>
+            <a:off x="521207" y="1170432"/>
+            <a:ext cx="1463040" cy="38100"/>
+          </a:xfrm>
+          <a:prstGeom prst="rect">
+            <a:avLst/>
+          </a:prstGeom>
+          <a:solidFill>
+            <a:srgbClr val="2B6CB0"/>
+          </a:solidFill>
+          <a:ln>
+            <a:noFill/>
+          </a:ln>
+          <a:effectLst/>
+        </p:spPr>
+        <p:style>
+          <a:lnRef idx="1">
+            <a:schemeClr val="accent1"/>
+          </a:lnRef>
+          <a:fillRef idx="3">
+            <a:schemeClr val="accent1"/>
+          </a:fillRef>
+          <a:effectRef idx="2">
+            <a:schemeClr val="accent1"/>
+          </a:effectRef>
+          <a:fontRef idx="minor">
+            <a:schemeClr val="lt1"/>
+          </a:fontRef>
+        </p:style>
+        <p:txBody>
+          <a:bodyPr rtlCol="0" anchor="ctr"/>
+          <a:lstStyle/>
+          <a:p>
+            <a:pPr algn="ctr"/>
+          </a:p>
+        </p:txBody>
+      </p:sp>
+      <p:sp>
+        <p:nvSpPr>
+          <p:cNvPr id="6" name="Rounded Rectangle 5"/>
+          <p:cNvSpPr/>
+          <p:nvPr/>
+        </p:nvSpPr>
+        <p:spPr>
+          <a:xfrm>
+            <a:off x="640080" y="1463040"/>
+            <a:ext cx="5212080" cy="457200"/>
+          </a:xfrm>
+          <a:prstGeom prst="roundRect">
+            <a:avLst/>
+          </a:prstGeom>
+          <a:solidFill>
+            <a:srgbClr val="E9F2FB"/>
+          </a:solidFill>
+          <a:ln w="15875">
+            <a:solidFill>
+              <a:srgbClr val="2B6CB0"/>
+            </a:solidFill>
+          </a:ln>
+          <a:effectLst/>
+        </p:spPr>
+        <p:style>
+          <a:lnRef idx="1">
+            <a:schemeClr val="accent1"/>
+          </a:lnRef>
+          <a:fillRef idx="3">
+            <a:schemeClr val="accent1"/>
+          </a:fillRef>
+          <a:effectRef idx="2">
+            <a:schemeClr val="accent1"/>
+          </a:effectRef>
+          <a:fontRef idx="minor">
+            <a:schemeClr val="lt1"/>
+          </a:fontRef>
+        </p:style>
+        <p:txBody>
+          <a:bodyPr rtlCol="0" anchor="ctr" wrap="square" lIns="50800" rIns="50800" tIns="25400" bIns="25400"/>
+          <a:lstStyle/>
+          <a:p>
+            <a:pPr algn="ctr"/>
+            <a:r>
+              <a:rPr sz="1400" b="1" i="0">
+                <a:solidFill>
+                  <a:srgbClr val="1F4E82"/>
+                </a:solidFill>
+                <a:latin typeface="Calibri"/>
+              </a:rPr>
+              <a:t>DOCKER</a:t>
+            </a:r>
+          </a:p>
+        </p:txBody>
+      </p:sp>
+      <p:sp>
+        <p:nvSpPr>
+          <p:cNvPr id="7" name="TextBox 6"/>
+          <p:cNvSpPr txBox="1"/>
+          <p:nvPr/>
+        </p:nvSpPr>
+        <p:spPr>
+          <a:xfrm>
+            <a:off x="640080" y="2057400"/>
+            <a:ext cx="5212080" cy="3931920"/>
+          </a:xfrm>
+          <a:prstGeom prst="rect">
+            <a:avLst/>
+          </a:prstGeom>
+          <a:noFill/>
+        </p:spPr>
+        <p:txBody>
+          <a:bodyPr wrap="square">
+            <a:spAutoFit/>
+          </a:bodyPr>
+          <a:lstStyle/>
+          <a:p>
+            <a:pPr>
+              <a:spcAft>
+                <a:spcPts val="1600"/>
+              </a:spcAft>
+            </a:pPr>
+            <a:r>
+              <a:rPr sz="1600">
+                <a:solidFill>
+                  <a:srgbClr val="3D4754"/>
+                </a:solidFill>
+                <a:latin typeface="Calibri"/>
+              </a:rPr>
+              <a:t>▪  One command: docker compose up --build</a:t>
+            </a:r>
+          </a:p>
+          <a:p>
+            <a:pPr>
+              <a:spcAft>
+                <a:spcPts val="1600"/>
+              </a:spcAft>
+            </a:pPr>
+            <a:r>
+              <a:rPr sz="1600">
+                <a:solidFill>
+                  <a:srgbClr val="3D4754"/>
+                </a:solidFill>
+                <a:latin typeface="Calibri"/>
+              </a:rPr>
+              <a:t>▪  SQLite data persists on the host, not in the image</a:t>
+            </a:r>
+          </a:p>
+          <a:p>
+            <a:pPr>
+              <a:spcAft>
+                <a:spcPts val="1600"/>
+              </a:spcAft>
+            </a:pPr>
+            <a:r>
+              <a:rPr sz="1600">
+                <a:solidFill>
+                  <a:srgbClr val="3D4754"/>
+                </a:solidFill>
+                <a:latin typeface="Calibri"/>
+              </a:rPr>
+              <a:t>▪  .env keys are injected at start, never copied into the image</a:t>
+            </a:r>
+          </a:p>
+          <a:p>
+            <a:pPr>
+              <a:spcAft>
+                <a:spcPts val="1600"/>
+              </a:spcAft>
+            </a:pPr>
+            <a:r>
+              <a:rPr sz="1600">
+                <a:solidFill>
+                  <a:srgbClr val="3D4754"/>
+                </a:solidFill>
+                <a:latin typeface="Calibri"/>
+              </a:rPr>
+              <a:t>▪  The MCP server runs on demand, not as an always-on service</a:t>
+            </a:r>
+          </a:p>
+        </p:txBody>
+      </p:sp>
+      <p:sp>
+        <p:nvSpPr>
+          <p:cNvPr id="8" name="Rounded Rectangle 7"/>
+          <p:cNvSpPr/>
+          <p:nvPr/>
+        </p:nvSpPr>
+        <p:spPr>
+          <a:xfrm>
+            <a:off x="6217920" y="1463040"/>
+            <a:ext cx="5303520" cy="457200"/>
+          </a:xfrm>
+          <a:prstGeom prst="roundRect">
+            <a:avLst/>
+          </a:prstGeom>
+          <a:solidFill>
+            <a:srgbClr val="E7F5EE"/>
+          </a:solidFill>
+          <a:ln w="15875">
+            <a:solidFill>
+              <a:srgbClr val="2F7D5C"/>
+            </a:solidFill>
+          </a:ln>
+          <a:effectLst/>
+        </p:spPr>
+        <p:style>
+          <a:lnRef idx="1">
+            <a:schemeClr val="accent1"/>
+          </a:lnRef>
+          <a:fillRef idx="3">
+            <a:schemeClr val="accent1"/>
+          </a:fillRef>
+          <a:effectRef idx="2">
+            <a:schemeClr val="accent1"/>
+          </a:effectRef>
+          <a:fontRef idx="minor">
+            <a:schemeClr val="lt1"/>
+          </a:fontRef>
+        </p:style>
+        <p:txBody>
+          <a:bodyPr rtlCol="0" anchor="ctr" wrap="square" lIns="50800" rIns="50800" tIns="25400" bIns="25400"/>
+          <a:lstStyle/>
+          <a:p>
+            <a:pPr algn="ctr"/>
+            <a:r>
+              <a:rPr sz="1400" b="1" i="0">
+                <a:solidFill>
+                  <a:srgbClr val="2F7D5C"/>
+                </a:solidFill>
+                <a:latin typeface="Calibri"/>
+              </a:rPr>
+              <a:t>OPENROUTER &amp; OLLAMA CLOUD</a:t>
+            </a:r>
+          </a:p>
+        </p:txBody>
+      </p:sp>
+      <p:sp>
+        <p:nvSpPr>
+          <p:cNvPr id="9" name="TextBox 8"/>
+          <p:cNvSpPr txBox="1"/>
+          <p:nvPr/>
+        </p:nvSpPr>
+        <p:spPr>
+          <a:xfrm>
+            <a:off x="6217920" y="2057400"/>
+            <a:ext cx="5303520" cy="3931920"/>
+          </a:xfrm>
+          <a:prstGeom prst="rect">
+            <a:avLst/>
+          </a:prstGeom>
+          <a:noFill/>
+        </p:spPr>
+        <p:txBody>
+          <a:bodyPr wrap="square">
+            <a:spAutoFit/>
+          </a:bodyPr>
+          <a:lstStyle/>
+          <a:p>
+            <a:pPr>
+              <a:spcAft>
+                <a:spcPts val="1600"/>
+              </a:spcAft>
+            </a:pPr>
+            <a:r>
+              <a:rPr sz="1600">
+                <a:solidFill>
+                  <a:srgbClr val="3D4754"/>
+                </a:solidFill>
+                <a:latin typeface="Calibri"/>
+              </a:rPr>
+              <a:t>▪  Both verified live, with a real API call, not assumed</a:t>
+            </a:r>
+          </a:p>
+          <a:p>
+            <a:pPr>
+              <a:spcAft>
+                <a:spcPts val="1600"/>
+              </a:spcAft>
+            </a:pPr>
+            <a:r>
+              <a:rPr sz="1600">
+                <a:solidFill>
+                  <a:srgbClr val="3D4754"/>
+                </a:solidFill>
+                <a:latin typeface="Calibri"/>
+              </a:rPr>
+              <a:t>▪  Neither needed a single line of provider-layer code</a:t>
+            </a:r>
+          </a:p>
+          <a:p>
+            <a:pPr>
+              <a:spcAft>
+                <a:spcPts val="1600"/>
+              </a:spcAft>
+            </a:pPr>
+            <a:r>
+              <a:rPr sz="1600">
+                <a:solidFill>
+                  <a:srgbClr val="3D4754"/>
+                </a:solidFill>
+                <a:latin typeface="Calibri"/>
+              </a:rPr>
+              <a:t>▪  Same ModelRouter, same OpenAICompatibleClient</a:t>
+            </a:r>
+          </a:p>
+          <a:p>
+            <a:pPr>
+              <a:spcAft>
+                <a:spcPts val="1600"/>
+              </a:spcAft>
+            </a:pPr>
+            <a:r>
+              <a:rPr sz="1600">
+                <a:solidFill>
+                  <a:srgbClr val="3D4754"/>
+                </a:solidFill>
+                <a:latin typeface="Calibri"/>
+              </a:rPr>
+              <a:t>▪  Switching provider is a config change, never a code change</a:t>
+            </a:r>
+          </a:p>
+        </p:txBody>
+      </p:sp>
+      <p:sp>
+        <p:nvSpPr>
+          <p:cNvPr id="10" name="TextBox 10"/>
+          <p:cNvSpPr txBox="1"/>
+          <p:nvPr/>
+        </p:nvSpPr>
+        <p:spPr>
+          <a:xfrm>
+            <a:off x="502920" y="6537960"/>
+            <a:ext cx="5486400" cy="274320"/>
+          </a:xfrm>
+          <a:prstGeom prst="rect">
+            <a:avLst/>
+          </a:prstGeom>
+          <a:noFill/>
+        </p:spPr>
+        <p:txBody>
+          <a:bodyPr wrap="square">
+            <a:spAutoFit/>
+          </a:bodyPr>
+          <a:lstStyle/>
+          <a:p>
+            <a:pPr algn="l"/>
+            <a:r>
+              <a:rPr sz="900" b="0" i="0">
+                <a:solidFill>
+                  <a:srgbClr val="6B7480"/>
+                </a:solidFill>
+                <a:latin typeface="Calibri"/>
+              </a:rPr>
+              <a:t>Job Application Agent</a:t>
+            </a:r>
+          </a:p>
+        </p:txBody>
+      </p:sp>
+      <p:sp>
+        <p:nvSpPr>
+          <p:cNvPr id="11" name="TextBox 11"/>
+          <p:cNvSpPr txBox="1"/>
+          <p:nvPr/>
+        </p:nvSpPr>
+        <p:spPr>
+          <a:xfrm>
+            <a:off x="11338560" y="6537960"/>
+            <a:ext cx="457200" cy="274320"/>
+          </a:xfrm>
+          <a:prstGeom prst="rect">
+            <a:avLst/>
+          </a:prstGeom>
+          <a:noFill/>
+        </p:spPr>
+        <p:txBody>
+          <a:bodyPr wrap="square">
+            <a:spAutoFit/>
+          </a:bodyPr>
+          <a:lstStyle/>
+          <a:p>
+            <a:pPr algn="r"/>
+            <a:r>
+              <a:rPr sz="900" b="0" i="0">
+                <a:solidFill>
+                  <a:srgbClr val="6B7480"/>
+                </a:solidFill>
+                <a:latin typeface="Calibri"/>
+              </a:rPr>
+              <a:t>16</a:t>
             </a:r>
           </a:p>
         </p:txBody>

</xml_diff>